<commit_message>
update: visual analytics, legal framing, rollout gates, and trade-offs
</commit_message>
<xml_diff>
--- a/Truecaller_Identity_Rights_Center_Product_Thinking_Deck.pptx
+++ b/Truecaller_Identity_Rights_Center_Product_Thinking_Deck.pptx
@@ -4001,7 +4001,7 @@
               </a:defRPr>
             </a:pPr>
             <a:r>
-              <a:t>Erase requests hide displayName listings, but preserve underlying spam signals.</a:t>
+              <a:t>Separate public identity visibility from safety-signal retention; retention policy requires legal and Trust &amp; Safety review.</a:t>
             </a:r>
           </a:p>
         </p:txBody>
@@ -4437,7 +4437,7 @@
               </a:defRPr>
             </a:pPr>
             <a:r>
-              <a:t>Trigger filters isolate low-risk updates for instant approval (future scope).</a:t>
+              <a:t>Trigger filters isolate low-risk updates for instant approval.</a:t>
             </a:r>
           </a:p>
         </p:txBody>
@@ -4978,7 +4978,7 @@
               </a:defRPr>
             </a:pPr>
             <a:r>
-              <a:t>• Consents only for their own data processing.</a:t>
+              <a:t>• Authorizes contact syncing through the active-user experience, while listed third parties may have no direct interaction with the product.</a:t>
             </a:r>
           </a:p>
           <a:p>
@@ -5089,7 +5089,7 @@
               </a:defRPr>
             </a:pPr>
             <a:r>
-              <a:t>• DPDP Access &amp; Correction Rights: Data subjects must have accessible pathways to check and correct directory inaccuracies.</a:t>
+              <a:t>• Compliance design assumption: provide transparent pathways to understand listed data, correct inaccuracies, request erasure where applicable, and raise grievances.</a:t>
             </a:r>
           </a:p>
           <a:p>
@@ -5121,7 +5121,7 @@
               </a:defRPr>
             </a:pPr>
             <a:r>
-              <a:t>• Strategic Trust Advantage: Proactively offering agency avoids litigation risks and converts skeptics to active users.</a:t>
+              <a:t>• Strategic Trust Advantage: Proactively offering agency reduces regulatory and reputational exposure while strengthening trust.</a:t>
             </a:r>
           </a:p>
         </p:txBody>
@@ -6328,7 +6328,7 @@
               </a:defRPr>
             </a:pPr>
             <a:r>
-              <a:t>Buried opt-out forms</a:t>
+              <a:t>Buried opt-out screens</a:t>
             </a:r>
           </a:p>
         </p:txBody>
@@ -6724,7 +6724,7 @@
               </a:defRPr>
             </a:pPr>
             <a:r>
-              <a:t>1. VERIFY</a:t>
+              <a:t>1. Verify</a:t>
             </a:r>
           </a:p>
           <a:p>
@@ -6840,7 +6840,7 @@
               </a:defRPr>
             </a:pPr>
             <a:r>
-              <a:t>2. UNDERSTAND</a:t>
+              <a:t>2. Understand</a:t>
             </a:r>
           </a:p>
           <a:p>
@@ -6956,7 +6956,7 @@
               </a:defRPr>
             </a:pPr>
             <a:r>
-              <a:t>3. CONTROL</a:t>
+              <a:t>3. Control</a:t>
             </a:r>
           </a:p>
           <a:p>
@@ -7072,7 +7072,7 @@
               </a:defRPr>
             </a:pPr>
             <a:r>
-              <a:t>4. TRACK</a:t>
+              <a:t>4. Track</a:t>
             </a:r>
           </a:p>
           <a:p>
@@ -7084,7 +7084,7 @@
               </a:defRPr>
             </a:pPr>
             <a:r>
-              <a:t>Stepper Steer Detail</a:t>
+              <a:t>Request Status &amp; Timeline</a:t>
             </a:r>
           </a:p>
         </p:txBody>
@@ -7358,7 +7358,7 @@
               </a:defRPr>
             </a:pPr>
             <a:r>
-              <a:t>SUPPORTING METRICS</a:t>
+              <a:t>SUPPORTING OPERATIONAL METRICS</a:t>
             </a:r>
           </a:p>
           <a:p>
@@ -7373,7 +7373,7 @@
               </a:defRPr>
             </a:pPr>
             <a:r>
-              <a:t>• OTP Success Rate: Onboarding drop-offs.</a:t>
+              <a:t>• OTP Success Rate: Funnel onboarding check.</a:t>
             </a:r>
           </a:p>
           <a:p>
@@ -7388,7 +7388,7 @@
               </a:defRPr>
             </a:pPr>
             <a:r>
-              <a:t>• Rights Action rate: correction vs erasure.</a:t>
+              <a:t>• Rights Action Completion Rate: Actions submitted.</a:t>
             </a:r>
           </a:p>
           <a:p>
@@ -7403,7 +7403,7 @@
               </a:defRPr>
             </a:pPr>
             <a:r>
-              <a:t>• Median Resolution SLA: Target &lt; 3 days.</a:t>
+              <a:t>• Median Resolution Time: Review queue wait.</a:t>
             </a:r>
           </a:p>
           <a:p>
@@ -7418,7 +7418,7 @@
               </a:defRPr>
             </a:pPr>
             <a:r>
-              <a:t>• Reopen / Repeat Rate: Follow-up complaints.</a:t>
+              <a:t>• Reopen / Repeat Contact Rate: Recurring complaints.</a:t>
             </a:r>
           </a:p>
         </p:txBody>
@@ -7619,13 +7619,13 @@
               </a:defRPr>
             </a:pPr>
             <a:r>
-              <a:t>90-DAY SUCCESS CRITERIA</a:t>
+              <a:t>ILLUSTRATIVE 90-DAY TARGETS</a:t>
             </a:r>
           </a:p>
           <a:p>
             <a:pPr>
               <a:spcBef>
-                <a:spcPts val="600"/>
+                <a:spcPts val="500"/>
               </a:spcBef>
               <a:defRPr sz="1150">
                 <a:solidFill>
@@ -7634,13 +7634,13 @@
               </a:defRPr>
             </a:pPr>
             <a:r>
-              <a:t>• Verified Agency Rate: &gt; 75% target.</a:t>
+              <a:t>• Verified Data Agency Rate &gt;75%</a:t>
             </a:r>
           </a:p>
           <a:p>
             <a:pPr>
               <a:spcBef>
-                <a:spcPts val="600"/>
+                <a:spcPts val="500"/>
               </a:spcBef>
               <a:defRPr sz="1150">
                 <a:solidFill>
@@ -7649,13 +7649,13 @@
               </a:defRPr>
             </a:pPr>
             <a:r>
-              <a:t>• OTP Success Rate: &gt; 85% target.</a:t>
+              <a:t>• OTP Success Rate &gt;85%</a:t>
             </a:r>
           </a:p>
           <a:p>
             <a:pPr>
               <a:spcBef>
-                <a:spcPts val="600"/>
+                <a:spcPts val="500"/>
               </a:spcBef>
               <a:defRPr sz="1150">
                 <a:solidFill>
@@ -7664,13 +7664,13 @@
               </a:defRPr>
             </a:pPr>
             <a:r>
-              <a:t>• Median SLA: &lt; 3 business days target.</a:t>
+              <a:t>• Median Resolution Time &lt;3 business days</a:t>
             </a:r>
           </a:p>
           <a:p>
             <a:pPr>
               <a:spcBef>
-                <a:spcPts val="600"/>
+                <a:spcPts val="500"/>
               </a:spcBef>
               <a:defRPr sz="1150">
                 <a:solidFill>
@@ -7679,13 +7679,13 @@
               </a:defRPr>
             </a:pPr>
             <a:r>
-              <a:t>• Portal CSAT: &gt; 85% positive rating.</a:t>
+              <a:t>• 95% of requests resolved within 5 business days</a:t>
             </a:r>
           </a:p>
           <a:p>
             <a:pPr>
               <a:spcBef>
-                <a:spcPts val="600"/>
+                <a:spcPts val="500"/>
               </a:spcBef>
               <a:defRPr sz="1150">
                 <a:solidFill>
@@ -7694,7 +7694,22 @@
               </a:defRPr>
             </a:pPr>
             <a:r>
-              <a:t>• Illustrative targets based on soft-launch models.</a:t>
+              <a:t>• Portal CSAT &gt;85%</a:t>
+            </a:r>
+          </a:p>
+          <a:p>
+            <a:pPr>
+              <a:spcBef>
+                <a:spcPts val="500"/>
+              </a:spcBef>
+              <a:defRPr sz="1150">
+                <a:solidFill>
+                  <a:srgbClr val="111318"/>
+                </a:solidFill>
+              </a:defRPr>
+            </a:pPr>
+            <a:r>
+              <a:t>• Note: Targets are illustrative targets based on models.</a:t>
             </a:r>
           </a:p>
         </p:txBody>
@@ -8692,7 +8707,7 @@
               </a:defRPr>
             </a:pPr>
             <a:r>
-              <a:t>PM Analytics: Dashboard Performance (Illustrative Data)</a:t>
+              <a:t>PM Analytics Dashboard Mock (Illustrative Data)</a:t>
             </a:r>
           </a:p>
         </p:txBody>
@@ -8705,7 +8720,7 @@
         </p:nvSpPr>
         <p:spPr>
           <a:xfrm>
-            <a:off x="731520" y="1554480"/>
+            <a:off x="731520" y="1371600"/>
             <a:ext cx="2514600" cy="1051560"/>
           </a:xfrm>
           <a:prstGeom prst="roundRect">
@@ -8748,7 +8763,7 @@
         </p:nvSpPr>
         <p:spPr>
           <a:xfrm>
-            <a:off x="731520" y="1645920"/>
+            <a:off x="731520" y="1463040"/>
             <a:ext cx="2514600" cy="914400"/>
           </a:xfrm>
           <a:prstGeom prst="rect">
@@ -8798,7 +8813,7 @@
         </p:nvSpPr>
         <p:spPr>
           <a:xfrm>
-            <a:off x="3429000" y="1554480"/>
+            <a:off x="3429000" y="1371600"/>
             <a:ext cx="2514600" cy="1051560"/>
           </a:xfrm>
           <a:prstGeom prst="roundRect">
@@ -8841,7 +8856,7 @@
         </p:nvSpPr>
         <p:spPr>
           <a:xfrm>
-            <a:off x="3429000" y="1645920"/>
+            <a:off x="3429000" y="1463040"/>
             <a:ext cx="2514600" cy="914400"/>
           </a:xfrm>
           <a:prstGeom prst="rect">
@@ -8891,7 +8906,7 @@
         </p:nvSpPr>
         <p:spPr>
           <a:xfrm>
-            <a:off x="6126480" y="1554480"/>
+            <a:off x="6126480" y="1371600"/>
             <a:ext cx="2514600" cy="1051560"/>
           </a:xfrm>
           <a:prstGeom prst="roundRect">
@@ -8934,7 +8949,7 @@
         </p:nvSpPr>
         <p:spPr>
           <a:xfrm>
-            <a:off x="6126480" y="1645920"/>
+            <a:off x="6126480" y="1463040"/>
             <a:ext cx="2514600" cy="914400"/>
           </a:xfrm>
           <a:prstGeom prst="rect">
@@ -8984,7 +8999,7 @@
         </p:nvSpPr>
         <p:spPr>
           <a:xfrm>
-            <a:off x="8823960" y="1554480"/>
+            <a:off x="8823960" y="1371600"/>
             <a:ext cx="2514600" cy="1051560"/>
           </a:xfrm>
           <a:prstGeom prst="roundRect">
@@ -9027,7 +9042,7 @@
         </p:nvSpPr>
         <p:spPr>
           <a:xfrm>
-            <a:off x="8823960" y="1645920"/>
+            <a:off x="8823960" y="1463040"/>
             <a:ext cx="2514600" cy="914400"/>
           </a:xfrm>
           <a:prstGeom prst="rect">
@@ -9077,8 +9092,8 @@
         </p:nvSpPr>
         <p:spPr>
           <a:xfrm>
-            <a:off x="731520" y="2834640"/>
-            <a:ext cx="5303520" cy="3291840"/>
+            <a:off x="731520" y="2560320"/>
+            <a:ext cx="10698480" cy="502920"/>
           </a:xfrm>
           <a:prstGeom prst="roundRect">
             <a:avLst/>
@@ -9120,8 +9135,8 @@
         </p:nvSpPr>
         <p:spPr>
           <a:xfrm>
-            <a:off x="822960" y="2926080"/>
-            <a:ext cx="5120640" cy="3108960"/>
+            <a:off x="822960" y="2606040"/>
+            <a:ext cx="10515600" cy="411480"/>
           </a:xfrm>
           <a:prstGeom prst="rect">
             <a:avLst/>
@@ -9135,106 +9150,46 @@
           <a:lstStyle/>
           <a:p>
             <a:pPr>
-              <a:defRPr b="1" sz="1200">
+              <a:defRPr b="1" sz="1100">
+                <a:solidFill>
+                  <a:srgbClr val="111318"/>
+                </a:solidFill>
+              </a:defRPr>
+            </a:pPr>
+            <a:r>
+              <a:t>Filters:  </a:t>
+            </a:r>
+            <a:r>
+              <a:rPr b="0">
                 <a:solidFill>
                   <a:srgbClr val="2B5CE0"/>
                 </a:solidFill>
-              </a:defRPr>
-            </a:pPr>
-            <a:r>
-              <a:t>CONVERSION FUNNEL (MOCKUP)</a:t>
-            </a:r>
-          </a:p>
-          <a:p>
-            <a:pPr>
-              <a:spcBef>
-                <a:spcPts val="800"/>
-              </a:spcBef>
-              <a:defRPr b="1" sz="1200">
-                <a:solidFill>
-                  <a:srgbClr val="111318"/>
-                </a:solidFill>
-              </a:defRPr>
-            </a:pPr>
-            <a:r>
-              <a:t>1. Intro Visits: </a:t>
+              </a:rPr>
+              <a:t>[Date Range: Last 30 Days]   </a:t>
             </a:r>
             <a:r>
               <a:rPr b="0">
                 <a:solidFill>
-                  <a:srgbClr val="4B5160"/>
+                  <a:srgbClr val="2B5CE0"/>
                 </a:solidFill>
               </a:rPr>
-              <a:t>128,450 (100%)</a:t>
-            </a:r>
-          </a:p>
-          <a:p>
-            <a:pPr>
-              <a:spcBef>
-                <a:spcPts val="800"/>
-              </a:spcBef>
-              <a:defRPr b="1" sz="1200">
-                <a:solidFill>
-                  <a:srgbClr val="111318"/>
-                </a:solidFill>
-              </a:defRPr>
-            </a:pPr>
-            <a:r>
-              <a:t>2. Phone Entered: </a:t>
+              <a:t>[Region: All States]   </a:t>
             </a:r>
             <a:r>
               <a:rPr b="0">
                 <a:solidFill>
-                  <a:srgbClr val="4B5160"/>
+                  <a:srgbClr val="2B5CE0"/>
                 </a:solidFill>
               </a:rPr>
-              <a:t>100,700 (78.4%)</a:t>
-            </a:r>
-          </a:p>
-          <a:p>
-            <a:pPr>
-              <a:spcBef>
-                <a:spcPts val="800"/>
-              </a:spcBef>
-              <a:defRPr b="1" sz="1200">
-                <a:solidFill>
-                  <a:srgbClr val="111318"/>
-                </a:solidFill>
-              </a:defRPr>
-            </a:pPr>
-            <a:r>
-              <a:t>3. OTP Verified: </a:t>
+              <a:t>[Device: Mobile/Web]   </a:t>
             </a:r>
             <a:r>
               <a:rPr b="0">
                 <a:solidFill>
-                  <a:srgbClr val="4B5160"/>
+                  <a:srgbClr val="2B5CE0"/>
                 </a:solidFill>
               </a:rPr>
-              <a:t>79,800 (62.1%)</a:t>
-            </a:r>
-          </a:p>
-          <a:p>
-            <a:pPr>
-              <a:spcBef>
-                <a:spcPts val="800"/>
-              </a:spcBef>
-              <a:defRPr b="1" sz="1200">
-                <a:solidFill>
-                  <a:srgbClr val="111318"/>
-                </a:solidFill>
-              </a:defRPr>
-            </a:pPr>
-            <a:r>
-              <a:t>4. Action Submitted: </a:t>
-            </a:r>
-            <a:r>
-              <a:rPr b="0">
-                <a:solidFill>
-                  <a:srgbClr val="4B5160"/>
-                </a:solidFill>
-              </a:rPr>
-              <a:t>62,560 (48.7%)</a:t>
+              <a:t>[Request Type: All]   </a:t>
             </a:r>
           </a:p>
         </p:txBody>
@@ -9247,8 +9202,8 @@
         </p:nvSpPr>
         <p:spPr>
           <a:xfrm>
-            <a:off x="6217920" y="2834640"/>
-            <a:ext cx="5212080" cy="3291840"/>
+            <a:off x="731520" y="3200400"/>
+            <a:ext cx="5303520" cy="3017520"/>
           </a:xfrm>
           <a:prstGeom prst="roundRect">
             <a:avLst/>
@@ -9290,8 +9245,8 @@
         </p:nvSpPr>
         <p:spPr>
           <a:xfrm>
-            <a:off x="6400800" y="2926080"/>
-            <a:ext cx="4846320" cy="3108960"/>
+            <a:off x="822960" y="3291840"/>
+            <a:ext cx="5120640" cy="2834640"/>
           </a:xfrm>
           <a:prstGeom prst="rect">
             <a:avLst/>
@@ -9305,82 +9260,965 @@
           <a:lstStyle/>
           <a:p>
             <a:pPr>
+              <a:defRPr b="1" sz="1100">
+                <a:solidFill>
+                  <a:srgbClr val="2B5CE0"/>
+                </a:solidFill>
+              </a:defRPr>
+            </a:pPr>
+            <a:r>
+              <a:t>VERIFIED DATA AGENCY RATE (8-WEEK TREND)</a:t>
+            </a:r>
+          </a:p>
+          <a:p>
+            <a:pPr>
+              <a:spcBef>
+                <a:spcPts val="14000"/>
+              </a:spcBef>
+              <a:defRPr sz="1100">
+                <a:solidFill>
+                  <a:srgbClr val="111318"/>
+                </a:solidFill>
+              </a:defRPr>
+            </a:pPr>
+            <a:r>
+              <a:t>W1: 52%  •  W2: 58%  •  W3: 63%  •  W4: 67%  •  W5: 71%  •  W6: 74%  •  W7: 76%  •  W8: 78.4%</a:t>
+            </a:r>
+          </a:p>
+        </p:txBody>
+      </p:sp>
+      <p:sp>
+        <p:nvSpPr>
+          <p:cNvPr id="16" name="Oval 15"/>
+          <p:cNvSpPr/>
+          <p:nvPr/>
+        </p:nvSpPr>
+        <p:spPr>
+          <a:xfrm>
+            <a:off x="1920240" y="8686800"/>
+            <a:ext cx="109728" cy="109728"/>
+          </a:xfrm>
+          <a:prstGeom prst="ellipse">
+            <a:avLst/>
+          </a:prstGeom>
+          <a:solidFill>
+            <a:srgbClr val="2B5CE0"/>
+          </a:solidFill>
+          <a:ln>
+            <a:noFill/>
+          </a:ln>
+        </p:spPr>
+        <p:style>
+          <a:lnRef idx="1">
+            <a:schemeClr val="accent1"/>
+          </a:lnRef>
+          <a:fillRef idx="3">
+            <a:schemeClr val="accent1"/>
+          </a:fillRef>
+          <a:effectRef idx="2">
+            <a:schemeClr val="accent1"/>
+          </a:effectRef>
+          <a:fontRef idx="minor">
+            <a:schemeClr val="lt1"/>
+          </a:fontRef>
+        </p:style>
+        <p:txBody>
+          <a:bodyPr rtlCol="0" anchor="ctr"/>
+          <a:lstStyle/>
+          <a:p>
+            <a:pPr algn="ctr"/>
+          </a:p>
+        </p:txBody>
+      </p:sp>
+      <p:sp>
+        <p:nvSpPr>
+          <p:cNvPr id="17" name="Oval 16"/>
+          <p:cNvSpPr/>
+          <p:nvPr/>
+        </p:nvSpPr>
+        <p:spPr>
+          <a:xfrm>
+            <a:off x="2468880" y="8503920"/>
+            <a:ext cx="109728" cy="109728"/>
+          </a:xfrm>
+          <a:prstGeom prst="ellipse">
+            <a:avLst/>
+          </a:prstGeom>
+          <a:solidFill>
+            <a:srgbClr val="2B5CE0"/>
+          </a:solidFill>
+          <a:ln>
+            <a:noFill/>
+          </a:ln>
+        </p:spPr>
+        <p:style>
+          <a:lnRef idx="1">
+            <a:schemeClr val="accent1"/>
+          </a:lnRef>
+          <a:fillRef idx="3">
+            <a:schemeClr val="accent1"/>
+          </a:fillRef>
+          <a:effectRef idx="2">
+            <a:schemeClr val="accent1"/>
+          </a:effectRef>
+          <a:fontRef idx="minor">
+            <a:schemeClr val="lt1"/>
+          </a:fontRef>
+        </p:style>
+        <p:txBody>
+          <a:bodyPr rtlCol="0" anchor="ctr"/>
+          <a:lstStyle/>
+          <a:p>
+            <a:pPr algn="ctr"/>
+          </a:p>
+        </p:txBody>
+      </p:sp>
+      <p:sp>
+        <p:nvSpPr>
+          <p:cNvPr id="18" name="Oval 17"/>
+          <p:cNvSpPr/>
+          <p:nvPr/>
+        </p:nvSpPr>
+        <p:spPr>
+          <a:xfrm>
+            <a:off x="3017520" y="8229600"/>
+            <a:ext cx="109728" cy="109728"/>
+          </a:xfrm>
+          <a:prstGeom prst="ellipse">
+            <a:avLst/>
+          </a:prstGeom>
+          <a:solidFill>
+            <a:srgbClr val="2B5CE0"/>
+          </a:solidFill>
+          <a:ln>
+            <a:noFill/>
+          </a:ln>
+        </p:spPr>
+        <p:style>
+          <a:lnRef idx="1">
+            <a:schemeClr val="accent1"/>
+          </a:lnRef>
+          <a:fillRef idx="3">
+            <a:schemeClr val="accent1"/>
+          </a:fillRef>
+          <a:effectRef idx="2">
+            <a:schemeClr val="accent1"/>
+          </a:effectRef>
+          <a:fontRef idx="minor">
+            <a:schemeClr val="lt1"/>
+          </a:fontRef>
+        </p:style>
+        <p:txBody>
+          <a:bodyPr rtlCol="0" anchor="ctr"/>
+          <a:lstStyle/>
+          <a:p>
+            <a:pPr algn="ctr"/>
+          </a:p>
+        </p:txBody>
+      </p:sp>
+      <p:sp>
+        <p:nvSpPr>
+          <p:cNvPr id="19" name="Oval 18"/>
+          <p:cNvSpPr/>
+          <p:nvPr/>
+        </p:nvSpPr>
+        <p:spPr>
+          <a:xfrm>
+            <a:off x="3566160" y="8046720"/>
+            <a:ext cx="109728" cy="109728"/>
+          </a:xfrm>
+          <a:prstGeom prst="ellipse">
+            <a:avLst/>
+          </a:prstGeom>
+          <a:solidFill>
+            <a:srgbClr val="2B5CE0"/>
+          </a:solidFill>
+          <a:ln>
+            <a:noFill/>
+          </a:ln>
+        </p:spPr>
+        <p:style>
+          <a:lnRef idx="1">
+            <a:schemeClr val="accent1"/>
+          </a:lnRef>
+          <a:fillRef idx="3">
+            <a:schemeClr val="accent1"/>
+          </a:fillRef>
+          <a:effectRef idx="2">
+            <a:schemeClr val="accent1"/>
+          </a:effectRef>
+          <a:fontRef idx="minor">
+            <a:schemeClr val="lt1"/>
+          </a:fontRef>
+        </p:style>
+        <p:txBody>
+          <a:bodyPr rtlCol="0" anchor="ctr"/>
+          <a:lstStyle/>
+          <a:p>
+            <a:pPr algn="ctr"/>
+          </a:p>
+        </p:txBody>
+      </p:sp>
+      <p:sp>
+        <p:nvSpPr>
+          <p:cNvPr id="20" name="Oval 19"/>
+          <p:cNvSpPr/>
+          <p:nvPr/>
+        </p:nvSpPr>
+        <p:spPr>
+          <a:xfrm>
+            <a:off x="4114800" y="7772400"/>
+            <a:ext cx="109728" cy="109728"/>
+          </a:xfrm>
+          <a:prstGeom prst="ellipse">
+            <a:avLst/>
+          </a:prstGeom>
+          <a:solidFill>
+            <a:srgbClr val="2B5CE0"/>
+          </a:solidFill>
+          <a:ln>
+            <a:noFill/>
+          </a:ln>
+        </p:spPr>
+        <p:style>
+          <a:lnRef idx="1">
+            <a:schemeClr val="accent1"/>
+          </a:lnRef>
+          <a:fillRef idx="3">
+            <a:schemeClr val="accent1"/>
+          </a:fillRef>
+          <a:effectRef idx="2">
+            <a:schemeClr val="accent1"/>
+          </a:effectRef>
+          <a:fontRef idx="minor">
+            <a:schemeClr val="lt1"/>
+          </a:fontRef>
+        </p:style>
+        <p:txBody>
+          <a:bodyPr rtlCol="0" anchor="ctr"/>
+          <a:lstStyle/>
+          <a:p>
+            <a:pPr algn="ctr"/>
+          </a:p>
+        </p:txBody>
+      </p:sp>
+      <p:sp>
+        <p:nvSpPr>
+          <p:cNvPr id="21" name="Oval 20"/>
+          <p:cNvSpPr/>
+          <p:nvPr/>
+        </p:nvSpPr>
+        <p:spPr>
+          <a:xfrm>
+            <a:off x="4663440" y="7589520"/>
+            <a:ext cx="109728" cy="109728"/>
+          </a:xfrm>
+          <a:prstGeom prst="ellipse">
+            <a:avLst/>
+          </a:prstGeom>
+          <a:solidFill>
+            <a:srgbClr val="2B5CE0"/>
+          </a:solidFill>
+          <a:ln>
+            <a:noFill/>
+          </a:ln>
+        </p:spPr>
+        <p:style>
+          <a:lnRef idx="1">
+            <a:schemeClr val="accent1"/>
+          </a:lnRef>
+          <a:fillRef idx="3">
+            <a:schemeClr val="accent1"/>
+          </a:fillRef>
+          <a:effectRef idx="2">
+            <a:schemeClr val="accent1"/>
+          </a:effectRef>
+          <a:fontRef idx="minor">
+            <a:schemeClr val="lt1"/>
+          </a:fontRef>
+        </p:style>
+        <p:txBody>
+          <a:bodyPr rtlCol="0" anchor="ctr"/>
+          <a:lstStyle/>
+          <a:p>
+            <a:pPr algn="ctr"/>
+          </a:p>
+        </p:txBody>
+      </p:sp>
+      <p:sp>
+        <p:nvSpPr>
+          <p:cNvPr id="22" name="Oval 21"/>
+          <p:cNvSpPr/>
+          <p:nvPr/>
+        </p:nvSpPr>
+        <p:spPr>
+          <a:xfrm>
+            <a:off x="5212080" y="7406640"/>
+            <a:ext cx="109728" cy="109728"/>
+          </a:xfrm>
+          <a:prstGeom prst="ellipse">
+            <a:avLst/>
+          </a:prstGeom>
+          <a:solidFill>
+            <a:srgbClr val="2B5CE0"/>
+          </a:solidFill>
+          <a:ln>
+            <a:noFill/>
+          </a:ln>
+        </p:spPr>
+        <p:style>
+          <a:lnRef idx="1">
+            <a:schemeClr val="accent1"/>
+          </a:lnRef>
+          <a:fillRef idx="3">
+            <a:schemeClr val="accent1"/>
+          </a:fillRef>
+          <a:effectRef idx="2">
+            <a:schemeClr val="accent1"/>
+          </a:effectRef>
+          <a:fontRef idx="minor">
+            <a:schemeClr val="lt1"/>
+          </a:fontRef>
+        </p:style>
+        <p:txBody>
+          <a:bodyPr rtlCol="0" anchor="ctr"/>
+          <a:lstStyle/>
+          <a:p>
+            <a:pPr algn="ctr"/>
+          </a:p>
+        </p:txBody>
+      </p:sp>
+      <p:sp>
+        <p:nvSpPr>
+          <p:cNvPr id="23" name="Oval 22"/>
+          <p:cNvSpPr/>
+          <p:nvPr/>
+        </p:nvSpPr>
+        <p:spPr>
+          <a:xfrm>
+            <a:off x="5760720" y="7223760"/>
+            <a:ext cx="109728" cy="109728"/>
+          </a:xfrm>
+          <a:prstGeom prst="ellipse">
+            <a:avLst/>
+          </a:prstGeom>
+          <a:solidFill>
+            <a:srgbClr val="2B5CE0"/>
+          </a:solidFill>
+          <a:ln>
+            <a:noFill/>
+          </a:ln>
+        </p:spPr>
+        <p:style>
+          <a:lnRef idx="1">
+            <a:schemeClr val="accent1"/>
+          </a:lnRef>
+          <a:fillRef idx="3">
+            <a:schemeClr val="accent1"/>
+          </a:fillRef>
+          <a:effectRef idx="2">
+            <a:schemeClr val="accent1"/>
+          </a:effectRef>
+          <a:fontRef idx="minor">
+            <a:schemeClr val="lt1"/>
+          </a:fontRef>
+        </p:style>
+        <p:txBody>
+          <a:bodyPr rtlCol="0" anchor="ctr"/>
+          <a:lstStyle/>
+          <a:p>
+            <a:pPr algn="ctr"/>
+          </a:p>
+        </p:txBody>
+      </p:sp>
+      <p:sp>
+        <p:nvSpPr>
+          <p:cNvPr id="24" name="Rounded Rectangle 23"/>
+          <p:cNvSpPr/>
+          <p:nvPr/>
+        </p:nvSpPr>
+        <p:spPr>
+          <a:xfrm>
+            <a:off x="6217920" y="3200400"/>
+            <a:ext cx="5212080" cy="3017520"/>
+          </a:xfrm>
+          <a:prstGeom prst="roundRect">
+            <a:avLst/>
+          </a:prstGeom>
+          <a:solidFill>
+            <a:srgbClr val="F5F6F8"/>
+          </a:solidFill>
+          <a:ln>
+            <a:noFill/>
+          </a:ln>
+        </p:spPr>
+        <p:style>
+          <a:lnRef idx="1">
+            <a:schemeClr val="accent1"/>
+          </a:lnRef>
+          <a:fillRef idx="3">
+            <a:schemeClr val="accent1"/>
+          </a:fillRef>
+          <a:effectRef idx="2">
+            <a:schemeClr val="accent1"/>
+          </a:effectRef>
+          <a:fontRef idx="minor">
+            <a:schemeClr val="lt1"/>
+          </a:fontRef>
+        </p:style>
+        <p:txBody>
+          <a:bodyPr rtlCol="0" anchor="ctr"/>
+          <a:lstStyle/>
+          <a:p>
+            <a:pPr algn="ctr"/>
+          </a:p>
+        </p:txBody>
+      </p:sp>
+      <p:sp>
+        <p:nvSpPr>
+          <p:cNvPr id="25" name="TextBox 24"/>
+          <p:cNvSpPr txBox="1"/>
+          <p:nvPr/>
+        </p:nvSpPr>
+        <p:spPr>
+          <a:xfrm>
+            <a:off x="6400800" y="3291840"/>
+            <a:ext cx="4846320" cy="2834640"/>
+          </a:xfrm>
+          <a:prstGeom prst="rect">
+            <a:avLst/>
+          </a:prstGeom>
+          <a:noFill/>
+        </p:spPr>
+        <p:txBody>
+          <a:bodyPr wrap="square">
+            <a:spAutoFit/>
+          </a:bodyPr>
+          <a:lstStyle/>
+          <a:p>
+            <a:pPr>
+              <a:defRPr b="1" sz="1100">
+                <a:solidFill>
+                  <a:srgbClr val="2B5CE0"/>
+                </a:solidFill>
+              </a:defRPr>
+            </a:pPr>
+            <a:r>
+              <a:t>CONVERSION FUNNEL &amp; REQUEST SPLIT</a:t>
+            </a:r>
+          </a:p>
+          <a:p>
+            <a:pPr>
+              <a:spcBef>
+                <a:spcPts val="14000"/>
+              </a:spcBef>
               <a:defRPr b="1" sz="1200">
                 <a:solidFill>
-                  <a:srgbClr val="1F9D63"/>
-                </a:solidFill>
-              </a:defRPr>
-            </a:pPr>
-            <a:r>
-              <a:t>SEGMENTATION &amp; FILTERS</a:t>
+                  <a:srgbClr val="111318"/>
+                </a:solidFill>
+              </a:defRPr>
+            </a:pPr>
+            <a:r>
+              <a:t>Request Category Split: Name Corrections = 68% | Erasure Requests = 32%</a:t>
             </a:r>
           </a:p>
           <a:p>
             <a:pPr>
               <a:spcBef>
-                <a:spcPts val="1200"/>
+                <a:spcPts val="400"/>
               </a:spcBef>
-              <a:defRPr sz="1200">
+              <a:defRPr i="1" sz="1000">
+                <a:solidFill>
+                  <a:srgbClr val="4B5160"/>
+                </a:solidFill>
+              </a:defRPr>
+            </a:pPr>
+            <a:r>
+              <a:t>* All figures are mock metrics presented for illustrative dashboard planning.</a:t>
+            </a:r>
+          </a:p>
+        </p:txBody>
+      </p:sp>
+      <p:sp>
+        <p:nvSpPr>
+          <p:cNvPr id="26" name="Rounded Rectangle 25"/>
+          <p:cNvSpPr/>
+          <p:nvPr/>
+        </p:nvSpPr>
+        <p:spPr>
+          <a:xfrm>
+            <a:off x="6400800" y="3566160"/>
+            <a:ext cx="4114800" cy="292608"/>
+          </a:xfrm>
+          <a:prstGeom prst="roundRect">
+            <a:avLst/>
+          </a:prstGeom>
+          <a:solidFill>
+            <a:srgbClr val="FFFFFF"/>
+          </a:solidFill>
+          <a:ln>
+            <a:noFill/>
+          </a:ln>
+        </p:spPr>
+        <p:style>
+          <a:lnRef idx="1">
+            <a:schemeClr val="accent1"/>
+          </a:lnRef>
+          <a:fillRef idx="3">
+            <a:schemeClr val="accent1"/>
+          </a:fillRef>
+          <a:effectRef idx="2">
+            <a:schemeClr val="accent1"/>
+          </a:effectRef>
+          <a:fontRef idx="minor">
+            <a:schemeClr val="lt1"/>
+          </a:fontRef>
+        </p:style>
+        <p:txBody>
+          <a:bodyPr rtlCol="0" anchor="ctr"/>
+          <a:lstStyle/>
+          <a:p>
+            <a:pPr algn="ctr"/>
+          </a:p>
+        </p:txBody>
+      </p:sp>
+      <p:sp>
+        <p:nvSpPr>
+          <p:cNvPr id="27" name="Rounded Rectangle 26"/>
+          <p:cNvSpPr/>
+          <p:nvPr/>
+        </p:nvSpPr>
+        <p:spPr>
+          <a:xfrm>
+            <a:off x="6400800" y="3566160"/>
+            <a:ext cx="3840480" cy="292608"/>
+          </a:xfrm>
+          <a:prstGeom prst="roundRect">
+            <a:avLst/>
+          </a:prstGeom>
+          <a:solidFill>
+            <a:srgbClr val="1E42A8"/>
+          </a:solidFill>
+          <a:ln>
+            <a:noFill/>
+          </a:ln>
+        </p:spPr>
+        <p:style>
+          <a:lnRef idx="1">
+            <a:schemeClr val="accent1"/>
+          </a:lnRef>
+          <a:fillRef idx="3">
+            <a:schemeClr val="accent1"/>
+          </a:fillRef>
+          <a:effectRef idx="2">
+            <a:schemeClr val="accent1"/>
+          </a:effectRef>
+          <a:fontRef idx="minor">
+            <a:schemeClr val="lt1"/>
+          </a:fontRef>
+        </p:style>
+        <p:txBody>
+          <a:bodyPr rtlCol="0" anchor="ctr"/>
+          <a:lstStyle/>
+          <a:p>
+            <a:pPr algn="ctr"/>
+          </a:p>
+        </p:txBody>
+      </p:sp>
+      <p:sp>
+        <p:nvSpPr>
+          <p:cNvPr id="28" name="TextBox 27"/>
+          <p:cNvSpPr txBox="1"/>
+          <p:nvPr/>
+        </p:nvSpPr>
+        <p:spPr>
+          <a:xfrm>
+            <a:off x="10314432" y="3520440"/>
+            <a:ext cx="182880" cy="292608"/>
+          </a:xfrm>
+          <a:prstGeom prst="rect">
+            <a:avLst/>
+          </a:prstGeom>
+          <a:noFill/>
+        </p:spPr>
+        <p:txBody>
+          <a:bodyPr wrap="none">
+            <a:spAutoFit/>
+          </a:bodyPr>
+          <a:lstStyle/>
+          <a:p>
+            <a:pPr>
+              <a:defRPr sz="1000" b="1">
                 <a:solidFill>
                   <a:srgbClr val="111318"/>
                 </a:solidFill>
               </a:defRPr>
             </a:pPr>
             <a:r>
-              <a:t>Action Category split: Name Corrections = 68% (42,540) | Erasure Requests = 32% (20,020)</a:t>
-            </a:r>
-          </a:p>
-          <a:p>
-            <a:pPr>
-              <a:spcBef>
-                <a:spcPts val="1000"/>
-              </a:spcBef>
-              <a:defRPr sz="1200">
-                <a:solidFill>
-                  <a:srgbClr val="4B5160"/>
-                </a:solidFill>
-              </a:defRPr>
-            </a:pPr>
-            <a:r>
-              <a:t>Device Splits: Mobile Web = 72% | Desktop Web = 28%</a:t>
-            </a:r>
-            <a:br/>
-            <a:r>
-              <a:t>Region Highlights: Karnataka (44%) | Maharashtra (28%)</a:t>
-            </a:r>
-          </a:p>
-          <a:p>
-            <a:pPr>
-              <a:spcBef>
-                <a:spcPts val="1400"/>
-              </a:spcBef>
-              <a:defRPr b="1" sz="1100">
-                <a:solidFill>
-                  <a:srgbClr val="2B5CE0"/>
-                </a:solidFill>
-              </a:defRPr>
-            </a:pPr>
-            <a:r>
-              <a:t>Available Dashboard Filters:</a:t>
-            </a:r>
-            <a:br/>
-            <a:r>
-              <a:t>Date Range  •  State/Region  •  Request Type  •  Device Group</a:t>
-            </a:r>
-          </a:p>
-          <a:p>
-            <a:pPr>
-              <a:spcBef>
-                <a:spcPts val="1400"/>
-              </a:spcBef>
-              <a:defRPr sz="1000" i="1">
-                <a:solidFill>
-                  <a:srgbClr val="4B5160"/>
-                </a:solidFill>
-              </a:defRPr>
-            </a:pPr>
-            <a:r>
-              <a:t>* All metrics listed above are illustrative target mocks for analytical visualization.</a:t>
+              <a:t>Portal Visits (100%)</a:t>
+            </a:r>
+          </a:p>
+        </p:txBody>
+      </p:sp>
+      <p:sp>
+        <p:nvSpPr>
+          <p:cNvPr id="29" name="Rounded Rectangle 28"/>
+          <p:cNvSpPr/>
+          <p:nvPr/>
+        </p:nvSpPr>
+        <p:spPr>
+          <a:xfrm>
+            <a:off x="6400800" y="3950208"/>
+            <a:ext cx="4114800" cy="292608"/>
+          </a:xfrm>
+          <a:prstGeom prst="roundRect">
+            <a:avLst/>
+          </a:prstGeom>
+          <a:solidFill>
+            <a:srgbClr val="FFFFFF"/>
+          </a:solidFill>
+          <a:ln>
+            <a:noFill/>
+          </a:ln>
+        </p:spPr>
+        <p:style>
+          <a:lnRef idx="1">
+            <a:schemeClr val="accent1"/>
+          </a:lnRef>
+          <a:fillRef idx="3">
+            <a:schemeClr val="accent1"/>
+          </a:fillRef>
+          <a:effectRef idx="2">
+            <a:schemeClr val="accent1"/>
+          </a:effectRef>
+          <a:fontRef idx="minor">
+            <a:schemeClr val="lt1"/>
+          </a:fontRef>
+        </p:style>
+        <p:txBody>
+          <a:bodyPr rtlCol="0" anchor="ctr"/>
+          <a:lstStyle/>
+          <a:p>
+            <a:pPr algn="ctr"/>
+          </a:p>
+        </p:txBody>
+      </p:sp>
+      <p:sp>
+        <p:nvSpPr>
+          <p:cNvPr id="30" name="Rounded Rectangle 29"/>
+          <p:cNvSpPr/>
+          <p:nvPr/>
+        </p:nvSpPr>
+        <p:spPr>
+          <a:xfrm>
+            <a:off x="6400800" y="3950208"/>
+            <a:ext cx="3017520" cy="292608"/>
+          </a:xfrm>
+          <a:prstGeom prst="roundRect">
+            <a:avLst/>
+          </a:prstGeom>
+          <a:solidFill>
+            <a:srgbClr val="2B5CE0"/>
+          </a:solidFill>
+          <a:ln>
+            <a:noFill/>
+          </a:ln>
+        </p:spPr>
+        <p:style>
+          <a:lnRef idx="1">
+            <a:schemeClr val="accent1"/>
+          </a:lnRef>
+          <a:fillRef idx="3">
+            <a:schemeClr val="accent1"/>
+          </a:fillRef>
+          <a:effectRef idx="2">
+            <a:schemeClr val="accent1"/>
+          </a:effectRef>
+          <a:fontRef idx="minor">
+            <a:schemeClr val="lt1"/>
+          </a:fontRef>
+        </p:style>
+        <p:txBody>
+          <a:bodyPr rtlCol="0" anchor="ctr"/>
+          <a:lstStyle/>
+          <a:p>
+            <a:pPr algn="ctr"/>
+          </a:p>
+        </p:txBody>
+      </p:sp>
+      <p:sp>
+        <p:nvSpPr>
+          <p:cNvPr id="31" name="TextBox 30"/>
+          <p:cNvSpPr txBox="1"/>
+          <p:nvPr/>
+        </p:nvSpPr>
+        <p:spPr>
+          <a:xfrm>
+            <a:off x="9491472" y="3904488"/>
+            <a:ext cx="1005840" cy="292608"/>
+          </a:xfrm>
+          <a:prstGeom prst="rect">
+            <a:avLst/>
+          </a:prstGeom>
+          <a:noFill/>
+        </p:spPr>
+        <p:txBody>
+          <a:bodyPr wrap="none">
+            <a:spAutoFit/>
+          </a:bodyPr>
+          <a:lstStyle/>
+          <a:p>
+            <a:pPr>
+              <a:defRPr sz="1000" b="1">
+                <a:solidFill>
+                  <a:srgbClr val="111318"/>
+                </a:solidFill>
+              </a:defRPr>
+            </a:pPr>
+            <a:r>
+              <a:t>Phone Entered (78.4%)</a:t>
+            </a:r>
+          </a:p>
+        </p:txBody>
+      </p:sp>
+      <p:sp>
+        <p:nvSpPr>
+          <p:cNvPr id="32" name="Rounded Rectangle 31"/>
+          <p:cNvSpPr/>
+          <p:nvPr/>
+        </p:nvSpPr>
+        <p:spPr>
+          <a:xfrm>
+            <a:off x="6400800" y="4334256"/>
+            <a:ext cx="4114800" cy="292608"/>
+          </a:xfrm>
+          <a:prstGeom prst="roundRect">
+            <a:avLst/>
+          </a:prstGeom>
+          <a:solidFill>
+            <a:srgbClr val="FFFFFF"/>
+          </a:solidFill>
+          <a:ln>
+            <a:noFill/>
+          </a:ln>
+        </p:spPr>
+        <p:style>
+          <a:lnRef idx="1">
+            <a:schemeClr val="accent1"/>
+          </a:lnRef>
+          <a:fillRef idx="3">
+            <a:schemeClr val="accent1"/>
+          </a:fillRef>
+          <a:effectRef idx="2">
+            <a:schemeClr val="accent1"/>
+          </a:effectRef>
+          <a:fontRef idx="minor">
+            <a:schemeClr val="lt1"/>
+          </a:fontRef>
+        </p:style>
+        <p:txBody>
+          <a:bodyPr rtlCol="0" anchor="ctr"/>
+          <a:lstStyle/>
+          <a:p>
+            <a:pPr algn="ctr"/>
+          </a:p>
+        </p:txBody>
+      </p:sp>
+      <p:sp>
+        <p:nvSpPr>
+          <p:cNvPr id="33" name="Rounded Rectangle 32"/>
+          <p:cNvSpPr/>
+          <p:nvPr/>
+        </p:nvSpPr>
+        <p:spPr>
+          <a:xfrm>
+            <a:off x="6400800" y="4334256"/>
+            <a:ext cx="2377440" cy="292608"/>
+          </a:xfrm>
+          <a:prstGeom prst="roundRect">
+            <a:avLst/>
+          </a:prstGeom>
+          <a:solidFill>
+            <a:srgbClr val="1F9D63"/>
+          </a:solidFill>
+          <a:ln>
+            <a:noFill/>
+          </a:ln>
+        </p:spPr>
+        <p:style>
+          <a:lnRef idx="1">
+            <a:schemeClr val="accent1"/>
+          </a:lnRef>
+          <a:fillRef idx="3">
+            <a:schemeClr val="accent1"/>
+          </a:fillRef>
+          <a:effectRef idx="2">
+            <a:schemeClr val="accent1"/>
+          </a:effectRef>
+          <a:fontRef idx="minor">
+            <a:schemeClr val="lt1"/>
+          </a:fontRef>
+        </p:style>
+        <p:txBody>
+          <a:bodyPr rtlCol="0" anchor="ctr"/>
+          <a:lstStyle/>
+          <a:p>
+            <a:pPr algn="ctr"/>
+          </a:p>
+        </p:txBody>
+      </p:sp>
+      <p:sp>
+        <p:nvSpPr>
+          <p:cNvPr id="34" name="TextBox 33"/>
+          <p:cNvSpPr txBox="1"/>
+          <p:nvPr/>
+        </p:nvSpPr>
+        <p:spPr>
+          <a:xfrm>
+            <a:off x="8851392" y="4288536"/>
+            <a:ext cx="1645920" cy="292608"/>
+          </a:xfrm>
+          <a:prstGeom prst="rect">
+            <a:avLst/>
+          </a:prstGeom>
+          <a:noFill/>
+        </p:spPr>
+        <p:txBody>
+          <a:bodyPr wrap="none">
+            <a:spAutoFit/>
+          </a:bodyPr>
+          <a:lstStyle/>
+          <a:p>
+            <a:pPr>
+              <a:defRPr sz="1000" b="1">
+                <a:solidFill>
+                  <a:srgbClr val="111318"/>
+                </a:solidFill>
+              </a:defRPr>
+            </a:pPr>
+            <a:r>
+              <a:t>OTP Verified (62.1%)</a:t>
+            </a:r>
+          </a:p>
+        </p:txBody>
+      </p:sp>
+      <p:sp>
+        <p:nvSpPr>
+          <p:cNvPr id="35" name="Rounded Rectangle 34"/>
+          <p:cNvSpPr/>
+          <p:nvPr/>
+        </p:nvSpPr>
+        <p:spPr>
+          <a:xfrm>
+            <a:off x="6400800" y="4718304"/>
+            <a:ext cx="4114800" cy="292608"/>
+          </a:xfrm>
+          <a:prstGeom prst="roundRect">
+            <a:avLst/>
+          </a:prstGeom>
+          <a:solidFill>
+            <a:srgbClr val="FFFFFF"/>
+          </a:solidFill>
+          <a:ln>
+            <a:noFill/>
+          </a:ln>
+        </p:spPr>
+        <p:style>
+          <a:lnRef idx="1">
+            <a:schemeClr val="accent1"/>
+          </a:lnRef>
+          <a:fillRef idx="3">
+            <a:schemeClr val="accent1"/>
+          </a:fillRef>
+          <a:effectRef idx="2">
+            <a:schemeClr val="accent1"/>
+          </a:effectRef>
+          <a:fontRef idx="minor">
+            <a:schemeClr val="lt1"/>
+          </a:fontRef>
+        </p:style>
+        <p:txBody>
+          <a:bodyPr rtlCol="0" anchor="ctr"/>
+          <a:lstStyle/>
+          <a:p>
+            <a:pPr algn="ctr"/>
+          </a:p>
+        </p:txBody>
+      </p:sp>
+      <p:sp>
+        <p:nvSpPr>
+          <p:cNvPr id="36" name="Rounded Rectangle 35"/>
+          <p:cNvSpPr/>
+          <p:nvPr/>
+        </p:nvSpPr>
+        <p:spPr>
+          <a:xfrm>
+            <a:off x="6400800" y="4718304"/>
+            <a:ext cx="1828800" cy="292608"/>
+          </a:xfrm>
+          <a:prstGeom prst="roundRect">
+            <a:avLst/>
+          </a:prstGeom>
+          <a:solidFill>
+            <a:srgbClr val="C57A11"/>
+          </a:solidFill>
+          <a:ln>
+            <a:noFill/>
+          </a:ln>
+        </p:spPr>
+        <p:style>
+          <a:lnRef idx="1">
+            <a:schemeClr val="accent1"/>
+          </a:lnRef>
+          <a:fillRef idx="3">
+            <a:schemeClr val="accent1"/>
+          </a:fillRef>
+          <a:effectRef idx="2">
+            <a:schemeClr val="accent1"/>
+          </a:effectRef>
+          <a:fontRef idx="minor">
+            <a:schemeClr val="lt1"/>
+          </a:fontRef>
+        </p:style>
+        <p:txBody>
+          <a:bodyPr rtlCol="0" anchor="ctr"/>
+          <a:lstStyle/>
+          <a:p>
+            <a:pPr algn="ctr"/>
+          </a:p>
+        </p:txBody>
+      </p:sp>
+      <p:sp>
+        <p:nvSpPr>
+          <p:cNvPr id="37" name="TextBox 36"/>
+          <p:cNvSpPr txBox="1"/>
+          <p:nvPr/>
+        </p:nvSpPr>
+        <p:spPr>
+          <a:xfrm>
+            <a:off x="8302752" y="4672584"/>
+            <a:ext cx="2194560" cy="292608"/>
+          </a:xfrm>
+          <a:prstGeom prst="rect">
+            <a:avLst/>
+          </a:prstGeom>
+          <a:noFill/>
+        </p:spPr>
+        <p:txBody>
+          <a:bodyPr wrap="none">
+            <a:spAutoFit/>
+          </a:bodyPr>
+          <a:lstStyle/>
+          <a:p>
+            <a:pPr>
+              <a:defRPr sz="1000" b="1">
+                <a:solidFill>
+                  <a:srgbClr val="111318"/>
+                </a:solidFill>
+              </a:defRPr>
+            </a:pPr>
+            <a:r>
+              <a:t>Action Completed (48.7%)</a:t>
             </a:r>
           </a:p>
         </p:txBody>
@@ -9586,7 +10424,7 @@
               </a:defRPr>
             </a:pPr>
             <a:r>
-              <a:t>Key Metric: OTP validation checks</a:t>
+              <a:t>Key Metric: OTP Validation success</a:t>
             </a:r>
           </a:p>
           <a:p>
@@ -9601,7 +10439,7 @@
               </a:defRPr>
             </a:pPr>
             <a:r>
-              <a:t>Rollback: Halt on route 404 bugs</a:t>
+              <a:t>Rollback: Halt on critical journey failure rate &gt;1%</a:t>
             </a:r>
           </a:p>
         </p:txBody>
@@ -9694,7 +10532,7 @@
               </a:defRPr>
             </a:pPr>
             <a:r>
-              <a:t> Karnataka state soft launch cohort</a:t>
+              <a:t>Karnataka state soft launch cohort</a:t>
             </a:r>
           </a:p>
           <a:p>
@@ -9709,7 +10547,7 @@
               </a:defRPr>
             </a:pPr>
             <a:r>
-              <a:t>Key Metric: Verified Agency Rate</a:t>
+              <a:t>Key Metric: Verified Data Agency Rate</a:t>
             </a:r>
           </a:p>
           <a:p>
@@ -9724,7 +10562,7 @@
               </a:defRPr>
             </a:pPr>
             <a:r>
-              <a:t>Rollback: Halt on drop-off &gt; 20%</a:t>
+              <a:t>Rollback: Halt on critical journey failure rate &gt;1%</a:t>
             </a:r>
           </a:p>
         </p:txBody>
@@ -9817,7 +10655,7 @@
               </a:defRPr>
             </a:pPr>
             <a:r>
-              <a:t>Additional selected state registries</a:t>
+              <a:t>Additional state cohorts</a:t>
             </a:r>
           </a:p>
           <a:p>
@@ -9832,7 +10670,7 @@
               </a:defRPr>
             </a:pPr>
             <a:r>
-              <a:t>Key Metric: Median resolution SLA</a:t>
+              <a:t>Key Metric: Median Resolution Time</a:t>
             </a:r>
           </a:p>
           <a:p>
@@ -9847,7 +10685,7 @@
               </a:defRPr>
             </a:pPr>
             <a:r>
-              <a:t>Rollback: Halt on SLA &gt; 5 days</a:t>
+              <a:t>Rollback: Halt on critical journey failure rate &gt;1%</a:t>
             </a:r>
           </a:p>
         </p:txBody>
@@ -9970,7 +10808,7 @@
               </a:defRPr>
             </a:pPr>
             <a:r>
-              <a:t>Rollback: Halt on CSAT &lt; 75%</a:t>
+              <a:t>Rollback: Halt on critical journey failure rate &gt;1%</a:t>
             </a:r>
           </a:p>
         </p:txBody>
@@ -10063,7 +10901,7 @@
               </a:defRPr>
             </a:pPr>
             <a:r>
-              <a:t>Mandatory rights access must NOT be withheld from control groups (legal compliance requirement). Instead, UX optimization experiments will test variants of layout copies, warning disclosure placements, and SMS resend reminders to maximize verification rates.</a:t>
+              <a:t>Experimentation boundary: do not withhold core rights-access pathways from eligible users. Test UX elements such as copy, information hierarchy, progressive disclosure, and reminder timing instead.</a:t>
             </a:r>
           </a:p>
         </p:txBody>

</xml_diff>